<commit_message>
Corrige bugs de análise: unidades de vazão, ordem de features, endpoint de tupans e consistência de dados
- simulador: vazão do ventilador padronizada em m³/h (antes L/min, 60x erro)
- simulador: corrige troca de ordem humidity/temperature no treinamento de ML e na acurácia
- simulador: adiciona GET /api/tupans; HTML usa endpoint real em loadTupans/clearTupans
- esquema_eletrico: alinha componentes (BMP280, DS18B20, nível capacitivo, OLED, relé+MOSFET, relé de transferência)
- diagramas_uml: estados da FSM (IDLE/INIT/COOLING/CONDENSING/FULL/ERROR), sensores e atuadores corrigidos
- imagens: curva de bateria 85W (~7h até 20%), gráfico de produção derivado do modelo físico
- pitch: R$ 1.223 e autonomia de 8h em vez de R$ 180/20h
- relatório: estatísticas §10 alinhadas ao modelo físico (0,12 L/h média, R² 0,98), custo por litro R$ 0,22
- testes: 43 testes, incluindo teste do endpoint GET /api/tupans
</commit_message>
<xml_diff>
--- a/Tupan_Water_Maker_Pitch.pptx
+++ b/Tupan_Water_Maker_Pitch.pptx
@@ -7065,7 +7065,7 @@
                 <a:latin typeface="Arial"/>
               </a:rPr>
               <a:t>BATERIA 12V 60Ah
-~20h de operação</a:t>
+~8h de operação</a:t>
             </a:r>
           </a:p>
         </p:txBody>
@@ -8561,7 +8561,7 @@
                 </a:solidFill>
                 <a:latin typeface="Arial"/>
               </a:rPr>
-              <a:t>R$ 180</a:t>
+              <a:t>R$ 1.223</a:t>
             </a:r>
           </a:p>
         </p:txBody>
@@ -8596,7 +8596,7 @@
                 </a:solidFill>
                 <a:latin typeface="Arial"/>
               </a:rPr>
-              <a:t>custo estimado</a:t>
+              <a:t>custo do protótipo</a:t>
             </a:r>
           </a:p>
         </p:txBody>
@@ -8701,7 +8701,7 @@
                 </a:solidFill>
                 <a:latin typeface="Arial"/>
               </a:rPr>
-              <a:t>20h</a:t>
+              <a:t>8h</a:t>
             </a:r>
           </a:p>
         </p:txBody>

</xml_diff>